<commit_message>
Generate all test files in this repository
document.docx and presentation.pptx were written by the sample script of
the viewer the renderers come from and still named it. Both are now
written by generate-docx-samples.mjs and generate-pptx-samples.mjs, with
the same structure and page counts (2 pages, 3 slides).

The README says the package is not on npm yet.

Co-Authored-By: Claude Opus 5.5 <noreply@anthropic.com>
</commit_message>
<xml_diff>
--- a/test/fixtures/presentation.pptx
+++ b/test/fixtures/presentation.pptx
@@ -5,25 +5,65 @@
     <p:sldMasterId id="2147483648" r:id="rId1"/>
   </p:sldMasterIdLst>
   <p:sldIdLst>
-    <p:sldId id="256" r:id="rId2"/>
-    <p:sldId id="257" r:id="rId3"/>
-    <p:sldId id="258" r:id="rId5"/>
+    <p:sldId id="256" r:id="rId10"/>
+    <p:sldId id="257" r:id="rId11"/>
+    <p:sldId id="258" r:id="rId12"/>
   </p:sldIdLst>
   <p:sldSz cx="12192000" cy="6858000"/>
   <p:notesSz cx="6858000" cy="9144000"/>
+  <p:defaultTextStyle>
+    <a:lvl1pPr>
+      <a:defRPr sz="1800">
+        <a:solidFill>
+          <a:schemeClr val="tx1"/>
+        </a:solidFill>
+        <a:latin typeface="+mn-lt"/>
+      </a:defRPr>
+    </a:lvl1pPr>
+  </p:defaultTextStyle>
 </p:presentation>
 </file>
 
 <file path=ppt/slideLayouts/slideLayout1.xml><?xml version="1.0" encoding="utf-8"?>
-<p:sldLayout xmlns:a="http://schemas.openxmlformats.org/drawingml/2006/main" xmlns:r="http://schemas.openxmlformats.org/officeDocument/2006/relationships" xmlns:p="http://schemas.openxmlformats.org/presentationml/2006/main" type="blank">
-  <p:cSld name="Blank">
+<p:sldLayout xmlns:a="http://schemas.openxmlformats.org/drawingml/2006/main" xmlns:r="http://schemas.openxmlformats.org/officeDocument/2006/relationships" xmlns:p="http://schemas.openxmlformats.org/presentationml/2006/main" type="titleOnly" preserve="1">
+  <p:cSld name="Title only">
     <p:spTree>
       <p:nvGrpSpPr>
         <p:cNvPr id="1" name=""/>
         <p:cNvGrpSpPr/>
         <p:nvPr/>
       </p:nvGrpSpPr>
-      <p:grpSpPr/>
+      <p:grpSpPr>
+        <a:xfrm>
+          <a:off x="0" y="0"/>
+          <a:ext cx="0" cy="0"/>
+          <a:chOff x="0" y="0"/>
+          <a:chExt cx="0" cy="0"/>
+        </a:xfrm>
+      </p:grpSpPr>
+      <p:sp>
+        <p:nvSpPr>
+          <p:cNvPr id="2" name="Title"/>
+          <p:cNvSpPr>
+            <a:spLocks noGrp="1"/>
+          </p:cNvSpPr>
+          <p:nvPr>
+            <p:ph type="title"/>
+          </p:nvPr>
+        </p:nvSpPr>
+        <p:spPr/>
+        <p:txBody>
+          <a:bodyPr/>
+          <a:lstStyle/>
+          <a:p>
+            <a:r>
+              <a:rPr lang="en-US"/>
+              <a:t>Title</a:t>
+            </a:r>
+            <a:endParaRPr lang="en-US"/>
+          </a:p>
+        </p:txBody>
+      </p:sp>
     </p:spTree>
   </p:cSld>
   <p:clrMapOvr>
@@ -33,15 +73,22 @@
 </file>
 
 <file path=ppt/slideLayouts/slideLayout2.xml><?xml version="1.0" encoding="utf-8"?>
-<p:sldLayout xmlns:a="http://schemas.openxmlformats.org/drawingml/2006/main" xmlns:r="http://schemas.openxmlformats.org/officeDocument/2006/relationships" xmlns:p="http://schemas.openxmlformats.org/presentationml/2006/main" type="obj">
-  <p:cSld name="Title and Content">
+<p:sldLayout xmlns:a="http://schemas.openxmlformats.org/drawingml/2006/main" xmlns:r="http://schemas.openxmlformats.org/officeDocument/2006/relationships" xmlns:p="http://schemas.openxmlformats.org/presentationml/2006/main" type="obj" preserve="1">
+  <p:cSld name="Title and content">
     <p:spTree>
       <p:nvGrpSpPr>
         <p:cNvPr id="1" name=""/>
         <p:cNvGrpSpPr/>
         <p:nvPr/>
       </p:nvGrpSpPr>
-      <p:grpSpPr/>
+      <p:grpSpPr>
+        <a:xfrm>
+          <a:off x="0" y="0"/>
+          <a:ext cx="0" cy="0"/>
+          <a:chOff x="0" y="0"/>
+          <a:chExt cx="0" cy="0"/>
+        </a:xfrm>
+      </p:grpSpPr>
       <p:sp>
         <p:nvSpPr>
           <p:cNvPr id="2" name="Title"/>
@@ -52,12 +99,7 @@
             <p:ph type="title"/>
           </p:nvPr>
         </p:nvSpPr>
-        <p:spPr>
-          <a:xfrm>
-            <a:off x="609600" y="365125"/>
-            <a:ext cx="10972800" cy="1325563"/>
-          </a:xfrm>
-        </p:spPr>
+        <p:spPr/>
         <p:txBody>
           <a:bodyPr/>
           <a:lstStyle/>
@@ -66,6 +108,7 @@
               <a:rPr lang="en-US"/>
               <a:t>Title</a:t>
             </a:r>
+            <a:endParaRPr lang="en-US"/>
           </a:p>
         </p:txBody>
       </p:sp>
@@ -79,12 +122,7 @@
             <p:ph idx="1"/>
           </p:nvPr>
         </p:nvSpPr>
-        <p:spPr>
-          <a:xfrm>
-            <a:off x="609600" y="1825625"/>
-            <a:ext cx="6400800" cy="4351338"/>
-          </a:xfrm>
-        </p:spPr>
+        <p:spPr/>
         <p:txBody>
           <a:bodyPr/>
           <a:lstStyle/>
@@ -93,6 +131,7 @@
               <a:rPr lang="en-US"/>
               <a:t>Text</a:t>
             </a:r>
+            <a:endParaRPr lang="en-US"/>
           </a:p>
         </p:txBody>
       </p:sp>
@@ -107,16 +146,50 @@
 <file path=ppt/slideMasters/slideMaster1.xml><?xml version="1.0" encoding="utf-8"?>
 <p:sldMaster xmlns:a="http://schemas.openxmlformats.org/drawingml/2006/main" xmlns:r="http://schemas.openxmlformats.org/officeDocument/2006/relationships" xmlns:p="http://schemas.openxmlformats.org/presentationml/2006/main">
   <p:cSld>
+    <p:bg>
+      <p:bgRef idx="1001">
+        <a:schemeClr val="bg1"/>
+      </p:bgRef>
+    </p:bg>
     <p:spTree>
       <p:nvGrpSpPr>
         <p:cNvPr id="1" name=""/>
         <p:cNvGrpSpPr/>
         <p:nvPr/>
       </p:nvGrpSpPr>
-      <p:grpSpPr/>
-      <p:sp>
-        <p:nvSpPr>
-          <p:cNvPr id="2" name="Title placeholder"/>
+      <p:grpSpPr>
+        <a:xfrm>
+          <a:off x="0" y="0"/>
+          <a:ext cx="0" cy="0"/>
+          <a:chOff x="0" y="0"/>
+          <a:chExt cx="0" cy="0"/>
+        </a:xfrm>
+      </p:grpSpPr>
+      <p:sp>
+        <p:nvSpPr>
+          <p:cNvPr id="9" name="Accent bar"/>
+          <p:cNvSpPr/>
+          <p:nvPr userDrawn="1"/>
+        </p:nvSpPr>
+        <p:spPr>
+          <a:xfrm>
+            <a:off x="0" y="0"/>
+            <a:ext cx="12192000" cy="76200"/>
+          </a:xfrm>
+          <a:prstGeom prst="rect">
+            <a:avLst/>
+          </a:prstGeom>
+          <a:solidFill>
+            <a:schemeClr val="accent1"/>
+          </a:solidFill>
+          <a:ln>
+            <a:noFill/>
+          </a:ln>
+        </p:spPr>
+      </p:sp>
+      <p:sp>
+        <p:nvSpPr>
+          <p:cNvPr id="2" name="Title"/>
           <p:cNvSpPr>
             <a:spLocks noGrp="1"/>
           </p:cNvSpPr>
@@ -126,8 +199,8 @@
         </p:nvSpPr>
         <p:spPr>
           <a:xfrm>
-            <a:off x="609600" y="365125"/>
-            <a:ext cx="10972800" cy="1325563"/>
+            <a:off x="457200" y="228600"/>
+            <a:ext cx="11277600" cy="635000"/>
           </a:xfrm>
         </p:spPr>
         <p:txBody>
@@ -138,12 +211,13 @@
               <a:rPr lang="en-US"/>
               <a:t>Title</a:t>
             </a:r>
-          </a:p>
-        </p:txBody>
-      </p:sp>
-      <p:sp>
-        <p:nvSpPr>
-          <p:cNvPr id="3" name="Text placeholder"/>
+            <a:endParaRPr lang="en-US"/>
+          </a:p>
+        </p:txBody>
+      </p:sp>
+      <p:sp>
+        <p:nvSpPr>
+          <p:cNvPr id="3" name="Text"/>
           <p:cNvSpPr>
             <a:spLocks noGrp="1"/>
           </p:cNvSpPr>
@@ -153,8 +227,8 @@
         </p:nvSpPr>
         <p:spPr>
           <a:xfrm>
-            <a:off x="609600" y="1825625"/>
-            <a:ext cx="10972800" cy="4351338"/>
+            <a:off x="457200" y="1016000"/>
+            <a:ext cx="11277600" cy="5207000"/>
           </a:xfrm>
         </p:spPr>
         <p:txBody>
@@ -165,6 +239,35 @@
               <a:rPr lang="en-US"/>
               <a:t>Text</a:t>
             </a:r>
+            <a:endParaRPr lang="en-US"/>
+          </a:p>
+        </p:txBody>
+      </p:sp>
+      <p:sp>
+        <p:nvSpPr>
+          <p:cNvPr id="4" name="Slide number"/>
+          <p:cNvSpPr>
+            <a:spLocks noGrp="1"/>
+          </p:cNvSpPr>
+          <p:nvPr>
+            <p:ph type="sldNum" sz="quarter" idx="12"/>
+          </p:nvPr>
+        </p:nvSpPr>
+        <p:spPr>
+          <a:xfrm>
+            <a:off x="10972800" y="6477000"/>
+            <a:ext cx="762000" cy="254000"/>
+          </a:xfrm>
+        </p:spPr>
+        <p:txBody>
+          <a:bodyPr/>
+          <a:lstStyle/>
+          <a:p>
+            <a:r>
+              <a:rPr lang="en-US"/>
+              <a:t>‹#›</a:t>
+            </a:r>
+            <a:endParaRPr lang="en-US"/>
           </a:p>
         </p:txBody>
       </p:sp>
@@ -173,12 +276,16 @@
   <p:clrMap bg1="lt1" tx1="dk1" bg2="lt2" tx2="dk2" accent1="accent1" accent2="accent2" accent3="accent3" accent4="accent4" accent5="accent5" accent6="accent6" hlink="hlink" folHlink="folHlink"/>
   <p:sldLayoutIdLst>
     <p:sldLayoutId id="2147483649" r:id="rId1"/>
-    <p:sldLayoutId id="2147483650" r:id="rId3"/>
+    <p:sldLayoutId id="2147483650" r:id="rId2"/>
   </p:sldLayoutIdLst>
   <p:txStyles>
     <p:titleStyle>
       <a:lvl1pPr algn="l">
-        <a:defRPr sz="4000" b="1">
+        <a:lnSpc>
+          <a:spcPct val="90000"/>
+        </a:lnSpc>
+        <a:buNone/>
+        <a:defRPr sz="3600">
           <a:solidFill>
             <a:schemeClr val="tx1"/>
           </a:solidFill>
@@ -187,20 +294,95 @@
       </a:lvl1pPr>
     </p:titleStyle>
     <p:bodyStyle>
-      <a:lvl1pPr marL="342900" indent="-342900">
+      <a:lvl1pPr marL="228600" indent="-228600" algn="l">
+        <a:lnSpc>
+          <a:spcPct val="90000"/>
+        </a:lnSpc>
+        <a:spcBef>
+          <a:spcPts val="1000"/>
+        </a:spcBef>
         <a:buFont typeface="Arial"/>
         <a:buChar char="•"/>
         <a:defRPr sz="2400">
           <a:solidFill>
-            <a:schemeClr val="accent1"/>
+            <a:schemeClr val="tx1"/>
           </a:solidFill>
           <a:latin typeface="+mn-lt"/>
         </a:defRPr>
       </a:lvl1pPr>
+      <a:lvl2pPr marL="571500" indent="-228600" algn="l">
+        <a:lnSpc>
+          <a:spcPct val="90000"/>
+        </a:lnSpc>
+        <a:spcBef>
+          <a:spcPts val="500"/>
+        </a:spcBef>
+        <a:buFont typeface="Arial"/>
+        <a:buChar char="•"/>
+        <a:defRPr sz="2000">
+          <a:solidFill>
+            <a:schemeClr val="tx1"/>
+          </a:solidFill>
+          <a:latin typeface="+mn-lt"/>
+        </a:defRPr>
+      </a:lvl2pPr>
+      <a:lvl3pPr marL="914400" indent="-228600" algn="l">
+        <a:lnSpc>
+          <a:spcPct val="90000"/>
+        </a:lnSpc>
+        <a:spcBef>
+          <a:spcPts val="500"/>
+        </a:spcBef>
+        <a:buFont typeface="Arial"/>
+        <a:buChar char="•"/>
+        <a:defRPr sz="1800">
+          <a:solidFill>
+            <a:schemeClr val="tx1"/>
+          </a:solidFill>
+          <a:latin typeface="+mn-lt"/>
+        </a:defRPr>
+      </a:lvl3pPr>
+      <a:lvl4pPr marL="1257300" indent="-228600" algn="l">
+        <a:lnSpc>
+          <a:spcPct val="90000"/>
+        </a:lnSpc>
+        <a:spcBef>
+          <a:spcPts val="500"/>
+        </a:spcBef>
+        <a:buFont typeface="Arial"/>
+        <a:buChar char="•"/>
+        <a:defRPr sz="1600">
+          <a:solidFill>
+            <a:schemeClr val="tx1"/>
+          </a:solidFill>
+          <a:latin typeface="+mn-lt"/>
+        </a:defRPr>
+      </a:lvl4pPr>
+      <a:lvl5pPr marL="1600200" indent="-228600" algn="l">
+        <a:lnSpc>
+          <a:spcPct val="90000"/>
+        </a:lnSpc>
+        <a:spcBef>
+          <a:spcPts val="500"/>
+        </a:spcBef>
+        <a:buFont typeface="Arial"/>
+        <a:buChar char="•"/>
+        <a:defRPr sz="1600">
+          <a:solidFill>
+            <a:schemeClr val="tx1"/>
+          </a:solidFill>
+          <a:latin typeface="+mn-lt"/>
+        </a:defRPr>
+      </a:lvl5pPr>
     </p:bodyStyle>
     <p:otherStyle>
       <a:lvl1pPr>
-        <a:defRPr sz="1800"/>
+        <a:defRPr sz="1800">
+          <a:solidFill>
+            <a:schemeClr val="tx1"/>
+          </a:solidFill>
+          <a:latin typeface="+mn-lt"/>
+        </a:defRPr>
       </a:lvl1pPr>
     </p:otherStyle>
   </p:txStyles>
@@ -224,10 +406,17 @@
         <p:cNvGrpSpPr/>
         <p:nvPr/>
       </p:nvGrpSpPr>
-      <p:grpSpPr/>
-      <p:sp>
-        <p:nvSpPr>
-          <p:cNvPr id="2" name="Shape 2"/>
+      <p:grpSpPr>
+        <a:xfrm>
+          <a:off x="0" y="0"/>
+          <a:ext cx="0" cy="0"/>
+          <a:chOff x="0" y="0"/>
+          <a:chExt cx="0" cy="0"/>
+        </a:xfrm>
+      </p:grpSpPr>
+      <p:sp>
+        <p:nvSpPr>
+          <p:cNvPr id="2" name="Band 2"/>
           <p:cNvSpPr/>
           <p:nvPr/>
         </p:nvSpPr>
@@ -240,7 +429,7 @@
             <a:avLst/>
           </a:prstGeom>
           <a:solidFill>
-            <a:srgbClr val="F29A38"/>
+            <a:schemeClr val="accent2"/>
           </a:solidFill>
           <a:ln>
             <a:noFill/>
@@ -249,7 +438,7 @@
       </p:sp>
       <p:sp>
         <p:nvSpPr>
-          <p:cNvPr id="3" name="Title"/>
+          <p:cNvPr id="3" name="Text box 3"/>
           <p:cNvSpPr txBox="1"/>
           <p:nvPr/>
         </p:nvSpPr>
@@ -263,24 +452,20 @@
           </a:prstGeom>
         </p:spPr>
         <p:txBody>
-          <a:bodyPr wrap="square"/>
-          <a:lstStyle/>
-          <a:p>
-            <a:r>
-              <a:rPr lang="en-US" sz="5400" b="1">
-                <a:solidFill>
-                  <a:srgbClr val="1B1E23"/>
-                </a:solidFill>
-                <a:latin typeface="Arial"/>
-              </a:rPr>
-              <a:t>Everything Viewer</a:t>
-            </a:r>
-          </a:p>
-        </p:txBody>
-      </p:sp>
-      <p:sp>
-        <p:nvSpPr>
-          <p:cNvPr id="4" name="Subtitle"/>
+          <a:bodyPr wrap="square" lIns="0" tIns="0" rIns="0" bIns="0"/>
+          <a:lstStyle/>
+          <a:p>
+            <a:r>
+              <a:rPr lang="en-US" sz="5400" b="1"/>
+              <a:t>ooxml-pages</a:t>
+            </a:r>
+            <a:endParaRPr lang="en-US"/>
+          </a:p>
+        </p:txBody>
+      </p:sp>
+      <p:sp>
+        <p:nvSpPr>
+          <p:cNvPr id="4" name="Text box 4"/>
           <p:cNvSpPr txBox="1"/>
           <p:nvPr/>
         </p:nvSpPr>
@@ -294,7 +479,7 @@
           </a:prstGeom>
         </p:spPr>
         <p:txBody>
-          <a:bodyPr wrap="square"/>
+          <a:bodyPr wrap="square" lIns="0" tIns="0" rIns="0" bIns="0"/>
           <a:lstStyle/>
           <a:p>
             <a:r>
@@ -302,10 +487,10 @@
                 <a:solidFill>
                   <a:srgbClr val="525B66"/>
                 </a:solidFill>
-                <a:latin typeface="Arial"/>
               </a:rPr>
-              <a:t>Sample presentation, generated by generate-samples.mjs</a:t>
-            </a:r>
+              <a:t>Sample presentation, written by scripts/generate-pptx-samples.mjs</a:t>
+            </a:r>
+            <a:endParaRPr lang="en-US"/>
           </a:p>
         </p:txBody>
       </p:sp>
@@ -320,49 +505,40 @@
 <file path=ppt/slides/slide2.xml><?xml version="1.0" encoding="utf-8"?>
 <p:sld xmlns:a="http://schemas.openxmlformats.org/drawingml/2006/main" xmlns:r="http://schemas.openxmlformats.org/officeDocument/2006/relationships" xmlns:p="http://schemas.openxmlformats.org/presentationml/2006/main">
   <p:cSld>
-    <p:bg>
-      <p:bgPr>
-        <a:solidFill>
-          <a:srgbClr val="FFFFFF"/>
-        </a:solidFill>
-        <a:effectLst/>
-      </p:bgPr>
-    </p:bg>
     <p:spTree>
       <p:nvGrpSpPr>
         <p:cNvPr id="1" name=""/>
         <p:cNvGrpSpPr/>
         <p:nvPr/>
       </p:nvGrpSpPr>
-      <p:grpSpPr/>
-      <p:sp>
-        <p:nvSpPr>
-          <p:cNvPr id="2" name="Title"/>
-          <p:cNvSpPr txBox="1"/>
-          <p:nvPr/>
-        </p:nvSpPr>
-        <p:spPr>
-          <a:xfrm>
-            <a:off x="609600" y="457200"/>
-            <a:ext cx="10972800" cy="914400"/>
-          </a:xfrm>
-          <a:prstGeom prst="rect">
-            <a:avLst/>
-          </a:prstGeom>
-        </p:spPr>
-        <p:txBody>
-          <a:bodyPr wrap="square"/>
-          <a:lstStyle/>
-          <a:p>
-            <a:r>
-              <a:rPr lang="en-US" sz="3600" b="1">
-                <a:solidFill>
-                  <a:srgbClr val="1B1E23"/>
-                </a:solidFill>
-                <a:latin typeface="Arial"/>
-              </a:rPr>
+      <p:grpSpPr>
+        <a:xfrm>
+          <a:off x="0" y="0"/>
+          <a:ext cx="0" cy="0"/>
+          <a:chOff x="0" y="0"/>
+          <a:chExt cx="0" cy="0"/>
+        </a:xfrm>
+      </p:grpSpPr>
+      <p:sp>
+        <p:nvSpPr>
+          <p:cNvPr id="2" name="Title 2"/>
+          <p:cNvSpPr>
+            <a:spLocks noGrp="1"/>
+          </p:cNvSpPr>
+          <p:nvPr>
+            <p:ph type="title"/>
+          </p:nvPr>
+        </p:nvSpPr>
+        <p:spPr/>
+        <p:txBody>
+          <a:bodyPr/>
+          <a:lstStyle/>
+          <a:p>
+            <a:r>
+              <a:rPr lang="en-US"/>
               <a:t>Second slide: shapes and picture</a:t>
             </a:r>
+            <a:endParaRPr lang="en-US"/>
           </a:p>
         </p:txBody>
       </p:sp>
@@ -381,47 +557,32 @@
             <a:avLst/>
           </a:prstGeom>
           <a:solidFill>
-            <a:srgbClr val="F29A38"/>
+            <a:schemeClr val="accent2"/>
           </a:solidFill>
           <a:ln>
             <a:noFill/>
           </a:ln>
         </p:spPr>
-      </p:sp>
-      <p:sp>
-        <p:nvSpPr>
-          <p:cNvPr id="4" name="Text 1"/>
-          <p:cNvSpPr txBox="1"/>
-          <p:nvPr/>
-        </p:nvSpPr>
-        <p:spPr>
-          <a:xfrm>
-            <a:off x="762000" y="2209800"/>
-            <a:ext cx="2895600" cy="609600"/>
-          </a:xfrm>
-          <a:prstGeom prst="rect">
-            <a:avLst/>
-          </a:prstGeom>
-        </p:spPr>
-        <p:txBody>
-          <a:bodyPr wrap="square"/>
-          <a:lstStyle/>
-          <a:p>
+        <p:txBody>
+          <a:bodyPr anchor="ctr"/>
+          <a:lstStyle/>
+          <a:p>
+            <a:pPr algn="ctr"/>
             <a:r>
               <a:rPr lang="en-US" sz="2000">
                 <a:solidFill>
-                  <a:srgbClr val="1B1E23"/>
+                  <a:schemeClr val="dk1"/>
                 </a:solidFill>
-                <a:latin typeface="Arial"/>
               </a:rPr>
               <a:t>Orange area</a:t>
             </a:r>
-          </a:p>
-        </p:txBody>
-      </p:sp>
-      <p:sp>
-        <p:nvSpPr>
-          <p:cNvPr id="5" name="Shape 5"/>
+            <a:endParaRPr lang="en-US"/>
+          </a:p>
+        </p:txBody>
+      </p:sp>
+      <p:sp>
+        <p:nvSpPr>
+          <p:cNvPr id="4" name="Shape 4"/>
           <p:cNvSpPr/>
           <p:nvPr/>
         </p:nvSpPr>
@@ -434,7 +595,7 @@
             <a:avLst/>
           </a:prstGeom>
           <a:solidFill>
-            <a:srgbClr val="5CC98B"/>
+            <a:schemeClr val="accent3"/>
           </a:solidFill>
           <a:ln>
             <a:noFill/>
@@ -443,8 +604,10 @@
       </p:sp>
       <p:pic>
         <p:nvPicPr>
-          <p:cNvPr id="6" name="Motif"/>
-          <p:cNvPicPr/>
+          <p:cNvPr id="5" name="Picture 5"/>
+          <p:cNvPicPr>
+            <a:picLocks noChangeAspect="1"/>
+          </p:cNvPicPr>
           <p:nvPr/>
         </p:nvPicPr>
         <p:blipFill>
@@ -474,24 +637,23 @@
 <file path=ppt/slides/slide3.xml><?xml version="1.0" encoding="utf-8"?>
 <p:sld xmlns:a="http://schemas.openxmlformats.org/drawingml/2006/main" xmlns:r="http://schemas.openxmlformats.org/officeDocument/2006/relationships" xmlns:p="http://schemas.openxmlformats.org/presentationml/2006/main">
   <p:cSld>
-    <p:bg>
-      <p:bgPr>
-        <a:solidFill>
-          <a:srgbClr val="FFFFFF"/>
-        </a:solidFill>
-        <a:effectLst/>
-      </p:bgPr>
-    </p:bg>
     <p:spTree>
       <p:nvGrpSpPr>
         <p:cNvPr id="1" name=""/>
         <p:cNvGrpSpPr/>
         <p:nvPr/>
       </p:nvGrpSpPr>
-      <p:grpSpPr/>
-      <p:sp>
-        <p:nvSpPr>
-          <p:cNvPr id="2" name="Title 1"/>
+      <p:grpSpPr>
+        <a:xfrm>
+          <a:off x="0" y="0"/>
+          <a:ext cx="0" cy="0"/>
+          <a:chOff x="0" y="0"/>
+          <a:chExt cx="0" cy="0"/>
+        </a:xfrm>
+      </p:grpSpPr>
+      <p:sp>
+        <p:nvSpPr>
+          <p:cNvPr id="6" name="Title 6"/>
           <p:cNvSpPr>
             <a:spLocks noGrp="1"/>
           </p:cNvSpPr>
@@ -508,12 +670,13 @@
               <a:rPr lang="en-US"/>
               <a:t>Third slide: placeholders and a group</a:t>
             </a:r>
-          </a:p>
-        </p:txBody>
-      </p:sp>
-      <p:sp>
-        <p:nvSpPr>
-          <p:cNvPr id="3" name="Content 2"/>
+            <a:endParaRPr lang="en-US"/>
+          </a:p>
+        </p:txBody>
+      </p:sp>
+      <p:sp>
+        <p:nvSpPr>
+          <p:cNvPr id="2" name="Content 2"/>
           <p:cNvSpPr>
             <a:spLocks noGrp="1"/>
           </p:cNvSpPr>
@@ -528,32 +691,35 @@
           <a:p>
             <a:r>
               <a:rPr lang="en-US"/>
-              <a:t>Position comes from the layout</a:t>
-            </a:r>
-          </a:p>
-          <a:p>
-            <a:r>
-              <a:rPr lang="en-US"/>
-              <a:t>Font and bullets come from the master</a:t>
-            </a:r>
-          </a:p>
-          <a:p>
-            <a:r>
-              <a:rPr lang="en-US"/>
-              <a:t>Right: two shapes in a group</a:t>
-            </a:r>
+              <a:t>Position, font and bullets come from the master</a:t>
+            </a:r>
+            <a:endParaRPr lang="en-US"/>
+          </a:p>
+          <a:p>
+            <a:r>
+              <a:rPr lang="en-US"/>
+              <a:t>The layout only names the placeholder</a:t>
+            </a:r>
+            <a:endParaRPr lang="en-US"/>
+          </a:p>
+          <a:p>
+            <a:r>
+              <a:rPr lang="en-US"/>
+              <a:t>Below on the right: two shapes in a group</a:t>
+            </a:r>
+            <a:endParaRPr lang="en-US"/>
           </a:p>
         </p:txBody>
       </p:sp>
       <p:grpSp>
         <p:nvGrpSpPr>
-          <p:cNvPr id="10" name="Group 1"/>
+          <p:cNvPr id="3" name="Group"/>
           <p:cNvGrpSpPr/>
           <p:nvPr/>
         </p:nvGrpSpPr>
         <p:grpSpPr>
           <a:xfrm>
-            <a:off x="7315200" y="2286000"/>
+            <a:off x="7315200" y="3810000"/>
             <a:ext cx="3657600" cy="1828800"/>
             <a:chOff x="0" y="0"/>
             <a:chExt cx="1828800" cy="914400"/>
@@ -561,47 +727,67 @@
         </p:grpSpPr>
         <p:sp>
           <p:nvSpPr>
-            <p:cNvPr id="11" name="Shape 11"/>
+            <p:cNvPr id="4" name="Shape 4"/>
             <p:cNvSpPr/>
             <p:nvPr/>
           </p:nvSpPr>
           <p:spPr>
             <a:xfrm>
               <a:off x="0" y="0"/>
-              <a:ext cx="880000" cy="914400"/>
+              <a:ext cx="876300" cy="914400"/>
             </a:xfrm>
             <a:prstGeom prst="rect">
               <a:avLst/>
             </a:prstGeom>
-            <a:solidFill>
-              <a:srgbClr val="F29A38"/>
-            </a:solidFill>
-            <a:ln>
-              <a:noFill/>
-            </a:ln>
           </p:spPr>
+          <p:style>
+            <a:lnRef idx="2">
+              <a:schemeClr val="accent2">
+                <a:shade val="50000"/>
+              </a:schemeClr>
+            </a:lnRef>
+            <a:fillRef idx="1">
+              <a:schemeClr val="accent2"/>
+            </a:fillRef>
+            <a:effectRef idx="0">
+              <a:schemeClr val="accent2"/>
+            </a:effectRef>
+            <a:fontRef idx="minor">
+              <a:schemeClr val="lt1"/>
+            </a:fontRef>
+          </p:style>
         </p:sp>
         <p:sp>
           <p:nvSpPr>
-            <p:cNvPr id="12" name="Shape 12"/>
+            <p:cNvPr id="5" name="Shape 5"/>
             <p:cNvSpPr/>
             <p:nvPr/>
           </p:nvSpPr>
           <p:spPr>
             <a:xfrm>
-              <a:off x="948800" y="0"/>
-              <a:ext cx="880000" cy="914400"/>
+              <a:off x="952500" y="0"/>
+              <a:ext cx="876300" cy="914400"/>
             </a:xfrm>
             <a:prstGeom prst="ellipse">
               <a:avLst/>
             </a:prstGeom>
-            <a:solidFill>
-              <a:srgbClr val="5CC98B"/>
-            </a:solidFill>
-            <a:ln>
-              <a:noFill/>
-            </a:ln>
           </p:spPr>
+          <p:style>
+            <a:lnRef idx="2">
+              <a:schemeClr val="accent3">
+                <a:shade val="50000"/>
+              </a:schemeClr>
+            </a:lnRef>
+            <a:fillRef idx="1">
+              <a:schemeClr val="accent3"/>
+            </a:fillRef>
+            <a:effectRef idx="0">
+              <a:schemeClr val="accent3"/>
+            </a:effectRef>
+            <a:fontRef idx="minor">
+              <a:schemeClr val="lt1"/>
+            </a:fontRef>
+          </p:style>
         </p:sp>
       </p:grpSp>
     </p:spTree>
@@ -613,9 +799,9 @@
 </file>
 
 <file path=ppt/theme/theme1.xml><?xml version="1.0" encoding="utf-8"?>
-<a:theme xmlns:a="http://schemas.openxmlformats.org/drawingml/2006/main" name="Everything">
+<a:theme xmlns:a="http://schemas.openxmlformats.org/drawingml/2006/main" name="Sample">
   <a:themeElements>
-    <a:clrScheme name="Everything">
+    <a:clrScheme name="Sample">
       <a:dk1>
         <a:srgbClr val="1B1E23"/>
       </a:dk1>
@@ -623,75 +809,95 @@
         <a:srgbClr val="FFFFFF"/>
       </a:lt1>
       <a:dk2>
-        <a:srgbClr val="2D323A"/>
+        <a:srgbClr val="2D3A4A"/>
       </a:dk2>
       <a:lt2>
-        <a:srgbClr val="F3F4F6"/>
+        <a:srgbClr val="EEF1F4"/>
       </a:lt2>
       <a:accent1>
-        <a:srgbClr val="F29A38"/>
+        <a:srgbClr val="2F6DB5"/>
       </a:accent1>
       <a:accent2>
-        <a:srgbClr val="5CC98B"/>
+        <a:srgbClr val="E2783A"/>
       </a:accent2>
       <a:accent3>
-        <a:srgbClr val="9AA6FF"/>
+        <a:srgbClr val="3E9C5C"/>
       </a:accent3>
       <a:accent4>
-        <a:srgbClr val="E8C547"/>
+        <a:srgbClr val="D9A82B"/>
       </a:accent4>
       <a:accent5>
-        <a:srgbClr val="F07470"/>
+        <a:srgbClr val="8A5BB8"/>
       </a:accent5>
       <a:accent6>
-        <a:srgbClr val="7F8994"/>
+        <a:srgbClr val="C94F64"/>
       </a:accent6>
       <a:hlink>
-        <a:srgbClr val="AD5A0C"/>
+        <a:srgbClr val="1F64C8"/>
       </a:hlink>
       <a:folHlink>
-        <a:srgbClr val="7F8994"/>
+        <a:srgbClr val="7B5AA6"/>
       </a:folHlink>
     </a:clrScheme>
-    <a:fontScheme name="Everything">
+    <a:fontScheme name="Sample">
       <a:majorFont>
-        <a:latin typeface="Arial"/>
+        <a:latin typeface="Calibri Light"/>
         <a:ea typeface=""/>
         <a:cs typeface=""/>
       </a:majorFont>
       <a:minorFont>
-        <a:latin typeface="Arial"/>
+        <a:latin typeface="Calibri"/>
         <a:ea typeface=""/>
         <a:cs typeface=""/>
       </a:minorFont>
     </a:fontScheme>
-    <a:fmtScheme name="Everything">
+    <a:fmtScheme name="Sample">
       <a:fillStyleLst>
         <a:solidFill>
           <a:schemeClr val="phClr"/>
         </a:solidFill>
+        <a:gradFill rotWithShape="1">
+          <a:gsLst>
+            <a:gs pos="0">
+              <a:schemeClr val="phClr">
+                <a:tint val="70000"/>
+              </a:schemeClr>
+            </a:gs>
+            <a:gs pos="100000">
+              <a:schemeClr val="phClr">
+                <a:shade val="90000"/>
+              </a:schemeClr>
+            </a:gs>
+          </a:gsLst>
+          <a:lin ang="5400000" scaled="0"/>
+        </a:gradFill>
         <a:solidFill>
-          <a:schemeClr val="phClr"/>
-        </a:solidFill>
-        <a:solidFill>
-          <a:schemeClr val="phClr"/>
+          <a:schemeClr val="phClr">
+            <a:shade val="80000"/>
+          </a:schemeClr>
         </a:solidFill>
       </a:fillStyleLst>
       <a:lnStyleLst>
-        <a:ln w="9525">
+        <a:ln w="6350" cap="flat" cmpd="sng" algn="ctr">
           <a:solidFill>
             <a:schemeClr val="phClr"/>
           </a:solidFill>
+          <a:prstDash val="solid"/>
+          <a:miter lim="800000"/>
         </a:ln>
-        <a:ln w="9525">
+        <a:ln w="12700" cap="flat" cmpd="sng" algn="ctr">
           <a:solidFill>
             <a:schemeClr val="phClr"/>
           </a:solidFill>
+          <a:prstDash val="solid"/>
+          <a:miter lim="800000"/>
         </a:ln>
-        <a:ln w="9525">
+        <a:ln w="19050" cap="flat" cmpd="sng" algn="ctr">
           <a:solidFill>
             <a:schemeClr val="phClr"/>
           </a:solidFill>
+          <a:prstDash val="solid"/>
+          <a:miter lim="800000"/>
         </a:ln>
       </a:lnStyleLst>
       <a:effectStyleLst>
@@ -710,11 +916,25 @@
           <a:schemeClr val="phClr"/>
         </a:solidFill>
         <a:solidFill>
-          <a:schemeClr val="phClr"/>
+          <a:schemeClr val="phClr">
+            <a:tint val="95000"/>
+          </a:schemeClr>
         </a:solidFill>
-        <a:solidFill>
-          <a:schemeClr val="phClr"/>
-        </a:solidFill>
+        <a:gradFill rotWithShape="1">
+          <a:gsLst>
+            <a:gs pos="0">
+              <a:schemeClr val="phClr">
+                <a:tint val="95000"/>
+              </a:schemeClr>
+            </a:gs>
+            <a:gs pos="100000">
+              <a:schemeClr val="phClr">
+                <a:shade val="85000"/>
+              </a:schemeClr>
+            </a:gs>
+          </a:gsLst>
+          <a:lin ang="5400000" scaled="0"/>
+        </a:gradFill>
       </a:bgFillStyleLst>
     </a:fmtScheme>
   </a:themeElements>

</xml_diff>